<commit_message>
poster, deck: sync to the report (199 tests, cross-region correlation, mean-leveling test)
- poster/build_v24.js: 194 -> 199 unit-test stat; "spatial correlation" ->
  "cross-region correlation"; "mean ablation(s)" -> "the mean-leveling test".
  Rebuilt poster_capstone_v24.{pptx,pdf}.
- scripts/build_deck.py: 194 -> 199 (186 in CI); "Mean-ablation" -> "the
  mean-leveling test". Rebuilt deck/capstone_defense.pptx.

Brings the Monday submission poster and the defense deck into line with the
report's terminology and test count.
</commit_message>
<xml_diff>
--- a/deck/capstone_defense.pptx
+++ b/deck/capstone_defense.pptx
@@ -3834,7 +3834,7 @@
         <p:spPr>
           <a:xfrm>
             <a:off x="640080" y="1417320"/>
-            <a:ext cx="6949440" cy="4301587"/>
+            <a:ext cx="6949440" cy="4426739"/>
           </a:xfrm>
           <a:prstGeom prst="rect">
             <a:avLst/>
@@ -5666,7 +5666,7 @@
         <p:spPr>
           <a:xfrm>
             <a:off x="6400800" y="1463040"/>
-            <a:ext cx="5212080" cy="2396538"/>
+            <a:ext cx="5212080" cy="2455099"/>
           </a:xfrm>
           <a:prstGeom prst="rect">
             <a:avLst/>
@@ -6230,7 +6230,7 @@
                 </a:solidFill>
                 <a:latin typeface="Segoe UI"/>
               </a:rPr>
-              <a:t>194 unit tests in CI; bootstrap confidence intervals on every gap.</a:t>
+              <a:t>199 unit tests (186 in CI); bootstrap confidence intervals on every gap.</a:t>
             </a:r>
           </a:p>
           <a:p>
@@ -6283,7 +6283,7 @@
         <p:spPr>
           <a:xfrm>
             <a:off x="6400800" y="1554480"/>
-            <a:ext cx="5212080" cy="1760706"/>
+            <a:ext cx="5212080" cy="1814503"/>
           </a:xfrm>
           <a:prstGeom prst="rect">
             <a:avLst/>
@@ -7381,7 +7381,7 @@
                 </a:solidFill>
                 <a:latin typeface="Segoe UI"/>
               </a:rPr>
-              <a:t>A reproducible, pre-registered pipeline under 194 unit tests.</a:t>
+              <a:t>A reproducible, pre-registered pipeline under 199 unit tests.</a:t>
             </a:r>
           </a:p>
         </p:txBody>
@@ -8347,7 +8347,7 @@
         <p:spPr>
           <a:xfrm>
             <a:off x="6400800" y="1463040"/>
-            <a:ext cx="5212080" cy="1222291"/>
+            <a:ext cx="5212080" cy="966780"/>
           </a:xfrm>
           <a:prstGeom prst="rect">
             <a:avLst/>
@@ -8798,7 +8798,7 @@
         <p:spPr>
           <a:xfrm>
             <a:off x="640080" y="1417320"/>
-            <a:ext cx="6583680" cy="3310008"/>
+            <a:ext cx="6583680" cy="3616573"/>
           </a:xfrm>
           <a:prstGeom prst="rect">
             <a:avLst/>
@@ -9505,7 +9505,7 @@
         <p:spPr>
           <a:xfrm>
             <a:off x="6400800" y="1554480"/>
-            <a:ext cx="5212080" cy="3086662"/>
+            <a:ext cx="5212080" cy="3054710"/>
           </a:xfrm>
           <a:prstGeom prst="rect">
             <a:avLst/>
@@ -10728,7 +10728,7 @@
         <p:spPr>
           <a:xfrm>
             <a:off x="6400800" y="1463040"/>
-            <a:ext cx="5212080" cy="1528122"/>
+            <a:ext cx="5212080" cy="1531000"/>
           </a:xfrm>
           <a:prstGeom prst="rect">
             <a:avLst/>
@@ -11179,7 +11179,7 @@
         <p:spPr>
           <a:xfrm>
             <a:off x="640080" y="1417320"/>
-            <a:ext cx="6949440" cy="4391183"/>
+            <a:ext cx="6949440" cy="4478809"/>
           </a:xfrm>
           <a:prstGeom prst="rect">
             <a:avLst/>
@@ -12323,7 +12323,7 @@
         <p:spPr>
           <a:xfrm>
             <a:off x="640080" y="1417320"/>
-            <a:ext cx="6766560" cy="1963683"/>
+            <a:ext cx="6766560" cy="2342780"/>
           </a:xfrm>
           <a:prstGeom prst="rect">
             <a:avLst/>
@@ -12915,7 +12915,7 @@
                 </a:solidFill>
                 <a:latin typeface="Segoe UI"/>
               </a:rPr>
-              <a:t>Mean-ablation: flatten the mean field and the covariance suddenly pays, up to +1.46%.</a:t>
+              <a:t>The mean-leveling test: flatten the mean field and the covariance suddenly pays, up to +1.46%.</a:t>
             </a:r>
           </a:p>
           <a:p>
@@ -12946,7 +12946,7 @@
                 </a:solidFill>
                 <a:latin typeface="Segoe UI"/>
               </a:rPr>
-              <a:t>So the spatial signal is real, but masked by the within-day mean carbon field.</a:t>
+              <a:t>So the cross-region signal is real, but masked by the within-day mean carbon field.</a:t>
             </a:r>
           </a:p>
           <a:p>

</xml_diff>

<commit_message>
Sync poster + deck to new title/202 count; add 2022-2023 walk-forward
- Rebuild poster (build_v24.js) and defense deck (build_deck.py) with the new
  title and 202-test count; regenerated pptx/pdf.
- Multi-year walk-forward: run the shuffled-marginals null for test years 2022
  and 2023 (train only on prior years) across all three grids. The null holds in
  every one; largest spatial gap 0.21% of CVaR, well within the 0.4% margin.
  Archive the six per-cell snapshots; cite in limitation (ii) of both theses.
</commit_message>
<xml_diff>
--- a/deck/capstone_defense.pptx
+++ b/deck/capstone_defense.pptx
@@ -3237,13 +3237,13 @@
               </a:spcAft>
             </a:pPr>
             <a:r>
-              <a:rPr sz="2500" b="1">
+              <a:rPr sz="2200" b="1">
                 <a:solidFill>
                   <a:srgbClr val="FFFFFF"/>
                 </a:solidFill>
                 <a:latin typeface="Georgia"/>
               </a:rPr>
-              <a:t>When Do Spatial and Robust Models Pay in</a:t>
+              <a:t>A Pre-Registered Falsification Test for When Spatial</a:t>
             </a:r>
           </a:p>
           <a:p>
@@ -3259,13 +3259,13 @@
               </a:spcAft>
             </a:pPr>
             <a:r>
-              <a:rPr sz="2500" b="1">
+              <a:rPr sz="2200" b="1">
                 <a:solidFill>
                   <a:srgbClr val="FFFFFF"/>
                 </a:solidFill>
                 <a:latin typeface="Georgia"/>
               </a:rPr>
-              <a:t>Carbon-Aware Data-Center Scheduling?</a:t>
+              <a:t>and Robust Modelling Pay in Carbon-Aware Scheduling</a:t>
             </a:r>
           </a:p>
         </p:txBody>
@@ -3834,7 +3834,7 @@
         <p:spPr>
           <a:xfrm>
             <a:off x="640080" y="1417320"/>
-            <a:ext cx="6949440" cy="4426739"/>
+            <a:ext cx="6949440" cy="4379803"/>
           </a:xfrm>
           <a:prstGeom prst="rect">
             <a:avLst/>
@@ -5666,7 +5666,7 @@
         <p:spPr>
           <a:xfrm>
             <a:off x="6400800" y="1463040"/>
-            <a:ext cx="5212080" cy="2455099"/>
+            <a:ext cx="5212080" cy="2621094"/>
           </a:xfrm>
           <a:prstGeom prst="rect">
             <a:avLst/>
@@ -6230,7 +6230,7 @@
                 </a:solidFill>
                 <a:latin typeface="Segoe UI"/>
               </a:rPr>
-              <a:t>199 unit tests (186 in CI); bootstrap confidence intervals on every gap.</a:t>
+              <a:t>202 unit tests (189 in CI); bootstrap confidence intervals on every gap.</a:t>
             </a:r>
           </a:p>
           <a:p>
@@ -6283,7 +6283,7 @@
         <p:spPr>
           <a:xfrm>
             <a:off x="6400800" y="1554480"/>
-            <a:ext cx="5212080" cy="1814503"/>
+            <a:ext cx="5212080" cy="2050884"/>
           </a:xfrm>
           <a:prstGeom prst="rect">
             <a:avLst/>
@@ -7381,7 +7381,7 @@
                 </a:solidFill>
                 <a:latin typeface="Segoe UI"/>
               </a:rPr>
-              <a:t>A reproducible, pre-registered pipeline under 199 unit tests.</a:t>
+              <a:t>A reproducible, pre-registered pipeline under 202 unit tests.</a:t>
             </a:r>
           </a:p>
         </p:txBody>
@@ -8798,7 +8798,7 @@
         <p:spPr>
           <a:xfrm>
             <a:off x="640080" y="1417320"/>
-            <a:ext cx="6583680" cy="3616573"/>
+            <a:ext cx="5770047" cy="4480560"/>
           </a:xfrm>
           <a:prstGeom prst="rect">
             <a:avLst/>
@@ -9505,7 +9505,7 @@
         <p:spPr>
           <a:xfrm>
             <a:off x="6400800" y="1554480"/>
-            <a:ext cx="5212080" cy="3054710"/>
+            <a:ext cx="5212080" cy="3253684"/>
           </a:xfrm>
           <a:prstGeom prst="rect">
             <a:avLst/>
@@ -10728,7 +10728,7 @@
         <p:spPr>
           <a:xfrm>
             <a:off x="6400800" y="1463040"/>
-            <a:ext cx="5212080" cy="1531000"/>
+            <a:ext cx="5212080" cy="1942268"/>
           </a:xfrm>
           <a:prstGeom prst="rect">
             <a:avLst/>
@@ -11179,7 +11179,7 @@
         <p:spPr>
           <a:xfrm>
             <a:off x="640080" y="1417320"/>
-            <a:ext cx="6949440" cy="4478809"/>
+            <a:ext cx="6949440" cy="4426739"/>
           </a:xfrm>
           <a:prstGeom prst="rect">
             <a:avLst/>
@@ -11751,7 +11751,7 @@
         <p:spPr>
           <a:xfrm>
             <a:off x="640080" y="1417320"/>
-            <a:ext cx="4503018" cy="4480560"/>
+            <a:ext cx="6949440" cy="4452081"/>
           </a:xfrm>
           <a:prstGeom prst="rect">
             <a:avLst/>
@@ -12323,7 +12323,7 @@
         <p:spPr>
           <a:xfrm>
             <a:off x="640080" y="1417320"/>
-            <a:ext cx="6766560" cy="2342780"/>
+            <a:ext cx="6766560" cy="2523068"/>
           </a:xfrm>
           <a:prstGeom prst="rect">
             <a:avLst/>

</xml_diff>

<commit_message>
Soften "pre-registered" to "pre-committed" (accuracy)
The work was not registered on a public registry; what was actually done is a
commit-lock of the analysis pipeline and per-case config in version control
before the held-out 2025 year was evaluated. "Pre-registered" overstated that, so
replace it with "pre-committed" / "commit-locked" throughout and retitle to
"A Pre-Committed Falsification Test ...". The underlying discipline (commit-lock,
single held-out test read, positive control) is unchanged; only the label is made
accurate. Defensible evidence is the public commit history (config locked
2026-05-25, before the test read).

Applied to all five deliverables (capstone, full, two-column paper, poster v24,
deck) + README + snapshot README + the alternate poster_a0; the H0/H1 box now
defines the pre-committed design explicitly (commit-locked before the held-out
year). Also fixed poster_a0's stale "187 unit tests" -> 202. All recompiled/rebuilt.
</commit_message>
<xml_diff>
--- a/deck/capstone_defense.pptx
+++ b/deck/capstone_defense.pptx
@@ -3243,7 +3243,7 @@
                 </a:solidFill>
                 <a:latin typeface="Georgia"/>
               </a:rPr>
-              <a:t>A Pre-Registered Falsification Test for When Spatial</a:t>
+              <a:t>A Pre-Committed Falsification Test for When Spatial</a:t>
             </a:r>
           </a:p>
           <a:p>
@@ -6137,7 +6137,7 @@
                 </a:solidFill>
                 <a:latin typeface="Segoe UI"/>
               </a:rPr>
-              <a:t>A pre-registered battery</a:t>
+              <a:t>A pre-committed battery</a:t>
             </a:r>
           </a:p>
           <a:p>
@@ -6261,7 +6261,7 @@
                 </a:solidFill>
                 <a:latin typeface="Segoe UI"/>
               </a:rPr>
-              <a:t>Pre-registered, version-controlled, with archived summary tables for every reported number.</a:t>
+              <a:t>Pre-committed, version-controlled, with archived summary tables for every reported number.</a:t>
             </a:r>
           </a:p>
         </p:txBody>
@@ -7381,7 +7381,7 @@
                 </a:solidFill>
                 <a:latin typeface="Segoe UI"/>
               </a:rPr>
-              <a:t>A reproducible, pre-registered pipeline under 202 unit tests.</a:t>
+              <a:t>A reproducible, pre-committed pipeline under 202 unit tests.</a:t>
             </a:r>
           </a:p>
         </p:txBody>
@@ -8325,7 +8325,7 @@
                 </a:solidFill>
                 <a:latin typeface="Segoe UI"/>
               </a:rPr>
-              <a:t>Pre-registered: if spatial structure matters, the joint schedule must win. It does not.</a:t>
+              <a:t>Pre-committed: if spatial structure matters, the joint schedule must win. It does not.</a:t>
             </a:r>
           </a:p>
         </p:txBody>

</xml_diff>

<commit_message>
Harden publication reproducibility and privacy
</commit_message>
<xml_diff>
--- a/deck/capstone_defense.pptx
+++ b/deck/capstone_defense.pptx
@@ -3834,7 +3834,7 @@
         <p:spPr>
           <a:xfrm>
             <a:off x="640080" y="1417320"/>
-            <a:ext cx="6949440" cy="4379803"/>
+            <a:ext cx="6949440" cy="4301587"/>
           </a:xfrm>
           <a:prstGeom prst="rect">
             <a:avLst/>
@@ -3940,7 +3940,7 @@
                 </a:solidFill>
                 <a:latin typeface="Segoe UI"/>
               </a:rPr>
-              <a:t>Real grids, tested across 17 zones, peak at only M near 1.4.</a:t>
+              <a:t>Real grids, tested across 17 zones, lie at joint-grid M = 1.29–1.89.</a:t>
             </a:r>
           </a:p>
           <a:p>
@@ -5666,7 +5666,7 @@
         <p:spPr>
           <a:xfrm>
             <a:off x="6400800" y="1463040"/>
-            <a:ext cx="5212080" cy="2621094"/>
+            <a:ext cx="5212080" cy="2396538"/>
           </a:xfrm>
           <a:prstGeom prst="rect">
             <a:avLst/>
@@ -6230,7 +6230,7 @@
                 </a:solidFill>
                 <a:latin typeface="Segoe UI"/>
               </a:rPr>
-              <a:t>202 unit tests (189 in CI); bootstrap confidence intervals on every gap.</a:t>
+              <a:t>202 tests (189 in public CI); bootstrap confidence intervals on every gap.</a:t>
             </a:r>
           </a:p>
           <a:p>
@@ -7350,7 +7350,7 @@
                 </a:solidFill>
                 <a:latin typeface="Segoe UI"/>
               </a:rPr>
-              <a:t>A price-of-robustness decision rule with a tested, data-grounded bound (M near 1.4 below M* near 3).</a:t>
+              <a:t>A price-of-robustness decision rule with a tested, data-grounded bound (joint-grid M = 1.29–1.89, below M* near 3).</a:t>
             </a:r>
           </a:p>
           <a:p>
@@ -7381,7 +7381,7 @@
                 </a:solidFill>
                 <a:latin typeface="Segoe UI"/>
               </a:rPr>
-              <a:t>A reproducible, pre-committed pipeline under 202 unit tests.</a:t>
+              <a:t>A reproducible, pre-committed pipeline under 202 tests.</a:t>
             </a:r>
           </a:p>
         </p:txBody>
@@ -8347,7 +8347,7 @@
         <p:spPr>
           <a:xfrm>
             <a:off x="6400800" y="1463040"/>
-            <a:ext cx="5212080" cy="966780"/>
+            <a:ext cx="5212080" cy="1222291"/>
           </a:xfrm>
           <a:prstGeom prst="rect">
             <a:avLst/>
@@ -8798,7 +8798,7 @@
         <p:spPr>
           <a:xfrm>
             <a:off x="640080" y="1417320"/>
-            <a:ext cx="5770047" cy="4480560"/>
+            <a:ext cx="6583680" cy="3310008"/>
           </a:xfrm>
           <a:prstGeom prst="rect">
             <a:avLst/>
@@ -9505,7 +9505,7 @@
         <p:spPr>
           <a:xfrm>
             <a:off x="6400800" y="1554480"/>
-            <a:ext cx="5212080" cy="3253684"/>
+            <a:ext cx="5212080" cy="3084700"/>
           </a:xfrm>
           <a:prstGeom prst="rect">
             <a:avLst/>
@@ -10728,7 +10728,7 @@
         <p:spPr>
           <a:xfrm>
             <a:off x="6400800" y="1463040"/>
-            <a:ext cx="5212080" cy="1942268"/>
+            <a:ext cx="5212080" cy="1941780"/>
           </a:xfrm>
           <a:prstGeom prst="rect">
             <a:avLst/>
@@ -11179,7 +11179,7 @@
         <p:spPr>
           <a:xfrm>
             <a:off x="640080" y="1417320"/>
-            <a:ext cx="6949440" cy="4426739"/>
+            <a:ext cx="6949440" cy="4391183"/>
           </a:xfrm>
           <a:prstGeom prst="rect">
             <a:avLst/>
@@ -11751,7 +11751,7 @@
         <p:spPr>
           <a:xfrm>
             <a:off x="640080" y="1417320"/>
-            <a:ext cx="6949440" cy="4452081"/>
+            <a:ext cx="6949440" cy="3163879"/>
           </a:xfrm>
           <a:prstGeom prst="rect">
             <a:avLst/>
@@ -12323,7 +12323,7 @@
         <p:spPr>
           <a:xfrm>
             <a:off x="640080" y="1417320"/>
-            <a:ext cx="6766560" cy="2523068"/>
+            <a:ext cx="6766560" cy="1963683"/>
           </a:xfrm>
           <a:prstGeom prst="rect">
             <a:avLst/>
@@ -13755,7 +13755,7 @@
         <p:spPr>
           <a:xfrm>
             <a:off x="6537959" y="2423160"/>
-            <a:ext cx="4937760" cy="622866"/>
+            <a:ext cx="4937760" cy="592713"/>
           </a:xfrm>
           <a:prstGeom prst="rect">
             <a:avLst/>

</xml_diff>